<commit_message>
Histor: internal price list, GPU-optional wording, architecture slide
- Pricing — Internal.md (internal only): $6,000 per site up to 8
  cameras, $400 per extra camera, all modules included, extra modules
  built on request $5,000, yearly $15 per camera per month (minimum
  $600), hardware (server, PoE switch, cameras, optional GPU) with
  placeholder prices and sizing rules. Partner study uses these numbers.
- Everywhere: a GPU is optional, not needed, to keep the customer's cost
  down (deck, Solutions and Technical PDFs, person-down sheet, video,
  histor.md, project summary). "GPU acceleration" removed from the
  technical sheet's roadmap: it already works.
- Deck: architecture slide ("Small parts, one pipeline"), slide 5
  detection illustration, Camera health / More rules / A second look
  redrawn; server slide titled "One server. A GPU is optional."

Co-Authored-By: Claude Opus 5.5 <noreply@anthropic.com>
</commit_message>
<xml_diff>
--- a/projects/histor/docs/Histor.pptx
+++ b/projects/histor/docs/Histor.pptx
@@ -746,7 +746,7 @@
           <a:lstStyle/>
           <a:p>
             <a:r>
-              <a:t>Detection uses YOLOX-S by default (about 76 ms a frame on a laptop CPU; YOLOX-M on a GPU server, Nano on weak machines) on ONNX Runtime and descriptions use CLIP, both on CPU. The detector reads the cheap sub stream; the main stream is saved as-is (about no CPU) in one-minute files, and full-resolution keyframes give sharp crops. On busy scenes the indexer samples more sparsely rather than lagging behind. Sizing note: 1080p at 4 Mbit/s is about 43 GB per camera per day of recording, 7 days kept by default. The 30 ms figure is a laptop CPU measurement for one CLIP crop (B/32 LAION-2B, October 2026).</a:t>
+              <a:t>Detection uses YOLOX-S by default (about 76 ms a frame on a laptop CPU; YOLOX-M on a GPU server, Nano on weak machines) on ONNX Runtime and descriptions use CLIP, both on CPU. No GPU is needed, which keeps the customer's cost down; a GPU is optional for more cameras per server or heavier models, and Histor uses it automatically when present. The detector reads the cheap sub stream; the main stream is saved as-is (about no CPU) in one-minute files, and full-resolution keyframes give sharp crops. On busy scenes the indexer samples more sparsely rather than lagging behind. Sizing note: 1080p at 4 Mbit/s is about 43 GB per camera per day of recording, 7 days kept by default. The 30 ms figure is a laptop CPU measurement for one CLIP crop (B/32 LAION-2B, October 2026).</a:t>
             </a:r>
           </a:p>
         </p:txBody>
@@ -2102,7 +2102,7 @@
           <a:p>
             <a:r>
               <a:rPr lang="en-US" dirty="0"/>
-              <a:t>From the Technical document. Runs on site on a standard Linux or Windows server or VM; cloud hosting is possible on request. CPU first; an NVIDIA GPU is only for many cameras or heavier models.</a:t>
+              <a:t>From the Technical document. Runs on site on a standard Linux or Windows server or VM; cloud hosting is possible on request. CPU first: no GPU needed, which keeps the customer's cost down; add an NVIDIA GPU only for more cameras per server or heavier models (Histor uses it automatically when present).</a:t>
             </a:r>
           </a:p>
           <a:p>
@@ -2261,7 +2261,7 @@
           <a:p>
             <a:r>
               <a:rPr lang="en-US" dirty="0"/>
-              <a:t>The five reasons from the brochure. Keep your cameras: no rip-and-replace. No special hardware to start: a standard server. Video stays on site: nothing has to leave the building. Fewer false alarms: rules tuned to the site, and alert checking by a local vision model before anything is sent. Grows with you: add cameras, sites and detections any time.</a:t>
+              <a:t>The five reasons from the brochure. Keep your cameras: no rip-and-replace. No special hardware to start: a standard server, and a GPU only when a site grows. Video stays on site: nothing has to leave the building. Fewer false alarms: rules tuned to the site, and alert checking by a local vision model before anything is sent. Grows with you: add cameras, sites and detections any time.</a:t>
             </a:r>
           </a:p>
           <a:p>
@@ -2397,7 +2397,7 @@
           <a:p>
             <a:r>
               <a:rPr lang="en-US" dirty="0"/>
-              <a:t>Two halves. Perception runs all the time: one recorder per camera, threads in one process on the server's CPU, no message bus. The light sub stream is analysed (YOLOX-S detector and tracker, one ID per object); full-resolution keyframes, about one a second, feed the indexes (CLIP for search, pose, and faces and plates where approved); audio goes to YAMNet when sound is switched on and is never stored. The main stream is recorded untouched by ffmpeg, an MP4 per minute.</a:t>
+              <a:t>Two halves. Perception runs all the time: one recorder per camera, threads in one process on the server's CPU (a GPU is optional and used automatically when present), no message bus. The light sub stream is analysed (YOLOX-S detector and tracker, one ID per object); full-resolution keyframes, about one a second, feed the indexes (CLIP for search, pose, and faces and plates where approved); audio goes to YAMNet when sound is switched on and is never stored. The main stream is recorded untouched by ffmpeg, an MP4 per minute.</a:t>
             </a:r>
           </a:p>
           <a:p>
@@ -8966,7 +8966,7 @@
                 <a:ea typeface="Arial" pitchFamily="34" charset="-122"/>
                 <a:cs typeface="Arial" pitchFamily="34" charset="-120"/>
               </a:rPr>
-              <a:t>One server. No GPU required.</a:t>
+              <a:t>One server. A GPU is optional.</a:t>
             </a:r>
             <a:endParaRPr lang="en-US" sz="3600" dirty="0"/>
           </a:p>
@@ -17405,7 +17405,7 @@
       </p:sp>
       <p:sp>
         <p:nvSpPr>
-          <p:cNvPr id="9" name="CPU first circle"/>
+          <p:cNvPr id="9" name="CPU first, GPU optional circle"/>
           <p:cNvSpPr/>
           <p:nvPr/>
         </p:nvSpPr>
@@ -17437,7 +17437,7 @@
       </p:sp>
       <p:pic>
         <p:nvPicPr>
-          <p:cNvPr id="10" name="CPU first icon" descr="cpu icon"/>
+          <p:cNvPr id="10" name="CPU first, GPU optional icon" descr="cpu icon"/>
           <p:cNvPicPr>
             <a:picLocks noChangeAspect="1"/>
           </p:cNvPicPr>
@@ -17489,7 +17489,7 @@
                   <a:schemeClr val="bg1"/>
                 </a:solidFill>
               </a:rPr>
-              <a:t>CPU first</a:t>
+              <a:t>CPU first, GPU optional</a:t>
             </a:r>
             <a:endParaRPr lang="en-US" sz="1700" dirty="0"/>
           </a:p>
@@ -17525,7 +17525,7 @@
                   <a:schemeClr val="bg2"/>
                 </a:solidFill>
               </a:rPr>
-              <a:t>A standard Linux or Windows server. Add an NVIDIA GPU later for many cameras or heavier models.</a:t>
+              <a:t>No GPU needed, which keeps the cost down. Add an NVIDIA GPU for more cameras per server or heavier models.</a:t>
             </a:r>
             <a:endParaRPr lang="en-US" sz="1300" dirty="0"/>
           </a:p>
@@ -18783,7 +18783,7 @@
                   <a:schemeClr val="bg2"/>
                 </a:solidFill>
               </a:rPr>
-              <a:t>Runs on a standard server, no graphics card to start.</a:t>
+              <a:t>A standard server. A GPU only when you grow.</a:t>
             </a:r>
             <a:endParaRPr lang="en-US" sz="1300" dirty="0"/>
           </a:p>
@@ -21062,7 +21062,7 @@
                 <a:ea typeface="Consolas" pitchFamily="34" charset="-122"/>
                 <a:cs typeface="Consolas" pitchFamily="34" charset="-120"/>
               </a:rPr>
-              <a:t>1  PERCEPTION · ONE RECORDER PER CAMERA, ON THE CPU</a:t>
+              <a:t>1  PERCEPTION · A RECORDER PER CAMERA · GPU OPTIONAL</a:t>
             </a:r>
             <a:endParaRPr lang="en-US" sz="1100" dirty="0"/>
           </a:p>

</xml_diff>